<commit_message>
Correct universal methods chain with replaymix base
</commit_message>
<xml_diff>
--- a/research/general_methods_chain_20260323_zh.pptx
+++ b/research/general_methods_chain_20260323_zh.pptx
@@ -16,6 +16,7 @@
     <p:sldId id="264" r:id="rId15"/>
     <p:sldId id="265" r:id="rId16"/>
     <p:sldId id="266" r:id="rId17"/>
+    <p:sldId id="267" r:id="rId18"/>
   </p:sldIdLst>
   <p:sldSz cx="12191695" cy="6858000" type="screen4x3"/>
   <p:notesSz cx="6858000" cy="9144000"/>
@@ -3114,7 +3115,7 @@
           <a:lstStyle/>
           <a:p>
             <a:r>
-              <a:t>通用连续学习方法链复验</a:t>
+              <a:t>通用方法链复验</a:t>
             </a:r>
           </a:p>
         </p:txBody>
@@ -3138,39 +3139,31 @@
               <a:defRPr sz="1800"/>
             </a:pPr>
             <a:r>
-              <a:t>固定预算口径下的通用 pipeline</a:t>
-            </a:r>
-          </a:p>
-          <a:p>
-            <a:pPr>
-              <a:defRPr sz="2200"/>
-            </a:pPr>
-            <a:r>
-              <a:t>目标：只保留适用于所有 task 的通用 continual 方法</a:t>
-            </a:r>
-          </a:p>
-          <a:p>
-            <a:pPr>
-              <a:defRPr sz="2200"/>
-            </a:pPr>
-            <a:r>
-              <a:t>统一标准：stage_epochs = 10,12,12；screen = 1 seed</a:t>
-            </a:r>
-          </a:p>
-          <a:p>
-            <a:pPr>
-              <a:defRPr sz="2200"/>
-            </a:pPr>
-            <a:r>
-              <a:t>从最原始 iCaRL（去掉 contrastive）开始逐步加方法</a:t>
-            </a:r>
-          </a:p>
-          <a:p>
-            <a:pPr>
-              <a:defRPr sz="2200"/>
-            </a:pPr>
-            <a:r>
-              <a:t>不使用 stage-specific prototype 修补或 asymmetric BCE</a:t>
+              <a:t>更合理底座：no contrastive + memory=36 + replaymix2</a:t>
+            </a:r>
+          </a:p>
+          <a:p>
+            <a:pPr>
+              <a:defRPr sz="2200"/>
+            </a:pPr>
+            <a:r>
+              <a:t>纠正上一版错误底座：这次从 mem36 + replaymix2 出发</a:t>
+            </a:r>
+          </a:p>
+          <a:p>
+            <a:pPr>
+              <a:defRPr sz="2200"/>
+            </a:pPr>
+            <a:r>
+              <a:t>统一目标：只看全 task 通用组件，不用 stage-specific trick</a:t>
+            </a:r>
+          </a:p>
+          <a:p>
+            <a:pPr>
+              <a:defRPr sz="2200"/>
+            </a:pPr>
+            <a:r>
+              <a:t>方法链仍按固定预算逐步叠加，但起点更合理</a:t>
             </a:r>
           </a:p>
         </p:txBody>
@@ -3209,7 +3202,7 @@
           <a:lstStyle/>
           <a:p>
             <a:r>
-              <a:t>和当前更强主线的关系</a:t>
+              <a:t>为什么 affine 和 hybrid 也没成立</a:t>
             </a:r>
           </a:p>
         </p:txBody>
@@ -3223,7 +3216,7 @@
         <p:spPr>
           <a:xfrm>
             <a:off x="731520" y="1234440"/>
-            <a:ext cx="10607040" cy="5029200"/>
+            <a:ext cx="10607040" cy="5120640"/>
           </a:xfrm>
           <a:prstGeom prst="rect">
             <a:avLst/>
@@ -3240,31 +3233,31 @@
               <a:defRPr sz="2200"/>
             </a:pPr>
             <a:r>
-              <a:t>更强 fixed-budget 主线：s2ace00_ptblendnew02_stage101212_confirm</a:t>
-            </a:r>
-          </a:p>
-          <a:p>
-            <a:pPr>
-              <a:defRPr sz="2200"/>
-            </a:pPr>
-            <a:r>
-              <a:t>结果：84.18 / 60.70 / 49.40</a:t>
-            </a:r>
-          </a:p>
-          <a:p>
-            <a:pPr>
-              <a:defRPr sz="2200"/>
-            </a:pPr>
-            <a:r>
-              <a:t>它更强，但包含明显更具阶段性的设计。</a:t>
-            </a:r>
-          </a:p>
-          <a:p>
-            <a:pPr>
-              <a:defRPr sz="2200"/>
-            </a:pPr>
-            <a:r>
-              <a:t>因此论文里可以分层叙述：先讲通用方法链，再讲场景增强版主线。</a:t>
+              <a:t>ugen06 affineall: 84.26 / 55.94 / 45.06</a:t>
+            </a:r>
+          </a:p>
+          <a:p>
+            <a:pPr>
+              <a:defRPr sz="2200"/>
+            </a:pPr>
+            <a:r>
+              <a:t>ugen07 hybridall: 84.26 / 55.17 / 45.99</a:t>
+            </a:r>
+          </a:p>
+          <a:p>
+            <a:pPr>
+              <a:defRPr sz="2200"/>
+            </a:pPr>
+            <a:r>
+              <a:t>把它们从 stage1/早期统一启用，并不会自然形成增益。</a:t>
+            </a:r>
+          </a:p>
+          <a:p>
+            <a:pPr>
+              <a:defRPr sz="2200"/>
+            </a:pPr>
+            <a:r>
+              <a:t>所以它们更适合被归类为条件性组件，而不是通用主线组件。</a:t>
             </a:r>
           </a:p>
         </p:txBody>
@@ -3303,7 +3296,7 @@
           <a:lstStyle/>
           <a:p>
             <a:r>
-              <a:t>推荐写法</a:t>
+              <a:t>当前通用链结论</a:t>
             </a:r>
           </a:p>
         </p:txBody>
@@ -3317,7 +3310,7 @@
         <p:spPr>
           <a:xfrm>
             <a:off x="731520" y="1234440"/>
-            <a:ext cx="10607040" cy="5029200"/>
+            <a:ext cx="10607040" cy="5120640"/>
           </a:xfrm>
           <a:prstGeom prst="rect">
             <a:avLst/>
@@ -3334,31 +3327,117 @@
               <a:defRPr sz="2200"/>
             </a:pPr>
             <a:r>
-              <a:t>基础 pipeline：no contrastive -&gt; normNME -&gt; LwF</a:t>
-            </a:r>
-          </a:p>
-          <a:p>
-            <a:pPr>
-              <a:defRPr sz="2200"/>
-            </a:pPr>
-            <a:r>
-              <a:t>说明 adapter/affine/hybrid 在“全任务统一启用”的严格标准下没有成立。</a:t>
-            </a:r>
-          </a:p>
-          <a:p>
-            <a:pPr>
-              <a:defRPr sz="2200"/>
-            </a:pPr>
-            <a:r>
-              <a:t>增强版方法再单独介绍：为什么需要 stage2-focused 机制。</a:t>
-            </a:r>
-          </a:p>
-          <a:p>
-            <a:pPr>
-              <a:defRPr sz="2200"/>
-            </a:pPr>
-            <a:r>
-              <a:t>这样方法故事会更清晰，也更符合你的论文目标。</a:t>
+              <a:t>更合理底座：mem36 + replaymix2</a:t>
+            </a:r>
+          </a:p>
+          <a:p>
+            <a:pPr>
+              <a:defRPr sz="2200"/>
+            </a:pPr>
+            <a:r>
+              <a:t>成立的通用点：10,12,12、normalized NME、LwF</a:t>
+            </a:r>
+          </a:p>
+          <a:p>
+            <a:pPr>
+              <a:defRPr sz="2200"/>
+            </a:pPr>
+            <a:r>
+              <a:t>不成立的通用点：adapter 全开、全局 oldweight、affine 全开、hybrid 早期开启</a:t>
+            </a:r>
+          </a:p>
+        </p:txBody>
+      </p:sp>
+    </p:spTree>
+  </p:cSld>
+  <p:clrMapOvr>
+    <a:masterClrMapping/>
+  </p:clrMapOvr>
+</p:sld>
+</file>
+
+<file path=ppt/slides/slide12.xml><?xml version="1.0" encoding="utf-8"?>
+<p:sld xmlns:a="http://schemas.openxmlformats.org/drawingml/2006/main" xmlns:p="http://schemas.openxmlformats.org/presentationml/2006/main" xmlns:r="http://schemas.openxmlformats.org/officeDocument/2006/relationships">
+  <p:cSld>
+    <p:spTree>
+      <p:nvGrpSpPr>
+        <p:cNvPr id="1" name=""/>
+        <p:cNvGrpSpPr/>
+        <p:nvPr/>
+      </p:nvGrpSpPr>
+      <p:grpSpPr/>
+      <p:sp>
+        <p:nvSpPr>
+          <p:cNvPr id="2" name="Title 1"/>
+          <p:cNvSpPr>
+            <a:spLocks noGrp="1"/>
+          </p:cNvSpPr>
+          <p:nvPr>
+            <p:ph type="title"/>
+          </p:nvPr>
+        </p:nvSpPr>
+        <p:spPr/>
+        <p:txBody>
+          <a:bodyPr/>
+          <a:lstStyle/>
+          <a:p>
+            <a:r>
+              <a:t>和更强主线的关系</a:t>
+            </a:r>
+          </a:p>
+        </p:txBody>
+      </p:sp>
+      <p:sp>
+        <p:nvSpPr>
+          <p:cNvPr id="3" name="TextBox 2"/>
+          <p:cNvSpPr txBox="1"/>
+          <p:nvPr/>
+        </p:nvSpPr>
+        <p:spPr>
+          <a:xfrm>
+            <a:off x="731520" y="1234440"/>
+            <a:ext cx="10607040" cy="5120640"/>
+          </a:xfrm>
+          <a:prstGeom prst="rect">
+            <a:avLst/>
+          </a:prstGeom>
+          <a:noFill/>
+        </p:spPr>
+        <p:txBody>
+          <a:bodyPr wrap="square">
+            <a:spAutoFit/>
+          </a:bodyPr>
+          <a:lstStyle/>
+          <a:p>
+            <a:pPr>
+              <a:defRPr sz="2200"/>
+            </a:pPr>
+            <a:r>
+              <a:t>更强 fixed-budget 主线仍然是 s2ace00_ptblendnew02_stage101212_confirm。</a:t>
+            </a:r>
+          </a:p>
+          <a:p>
+            <a:pPr>
+              <a:defRPr sz="2200"/>
+            </a:pPr>
+            <a:r>
+              <a:t>通用链回答的是“哪些组件能写成普适方法”。</a:t>
+            </a:r>
+          </a:p>
+          <a:p>
+            <a:pPr>
+              <a:defRPr sz="2200"/>
+            </a:pPr>
+            <a:r>
+              <a:t>增强主线回答的是“针对当前场景瓶颈，哪些阶段性方法最有效”。</a:t>
+            </a:r>
+          </a:p>
+          <a:p>
+            <a:pPr>
+              <a:defRPr sz="2200"/>
+            </a:pPr>
+            <a:r>
+              <a:t>这两套材料在论文里应该分层叙述，而不是混在一起。</a:t>
             </a:r>
           </a:p>
         </p:txBody>
@@ -3397,7 +3476,7 @@
           <a:lstStyle/>
           <a:p>
             <a:r>
-              <a:t>为什么要单独做这条链</a:t>
+              <a:t>为什么要重跑</a:t>
             </a:r>
           </a:p>
         </p:txBody>
@@ -3411,7 +3490,7 @@
         <p:spPr>
           <a:xfrm>
             <a:off x="731520" y="1234440"/>
-            <a:ext cx="10607040" cy="5029200"/>
+            <a:ext cx="10607040" cy="5120640"/>
           </a:xfrm>
           <a:prstGeom prst="rect">
             <a:avLst/>
@@ -3428,23 +3507,23 @@
               <a:defRPr sz="2200"/>
             </a:pPr>
             <a:r>
-              <a:t>之前更强的主线包含 stage2/stage3 条件性设计，虽然有效，但不够通用。</a:t>
-            </a:r>
-          </a:p>
-          <a:p>
-            <a:pPr>
-              <a:defRPr sz="2200"/>
-            </a:pPr>
-            <a:r>
-              <a:t>这次的目标不是追最高分，而是确认哪些组件能被写成“对所有 task 都适用”的方法。</a:t>
-            </a:r>
-          </a:p>
-          <a:p>
-            <a:pPr>
-              <a:defRPr sz="2200"/>
-            </a:pPr>
-            <a:r>
-              <a:t>因此本轮更关注方法的普适性和可解释性，而不是最终最优分数。</a:t>
+              <a:t>上一版通用链错误地从 mem24 + 无 replaymix 出发。</a:t>
+            </a:r>
+          </a:p>
+          <a:p>
+            <a:pPr>
+              <a:defRPr sz="2200"/>
+            </a:pPr>
+            <a:r>
+              <a:t>这会把很多本来依赖更合理 replay 底座的方法误判为无效。</a:t>
+            </a:r>
+          </a:p>
+          <a:p>
+            <a:pPr>
+              <a:defRPr sz="2200"/>
+            </a:pPr>
+            <a:r>
+              <a:t>因此必须从更接近真实强基线的底座重新做一遍链式验证。</a:t>
             </a:r>
           </a:p>
         </p:txBody>
@@ -3497,7 +3576,7 @@
         <p:spPr>
           <a:xfrm>
             <a:off x="731520" y="1234440"/>
-            <a:ext cx="10607040" cy="5029200"/>
+            <a:ext cx="10607040" cy="5120640"/>
           </a:xfrm>
           <a:prstGeom prst="rect">
             <a:avLst/>
@@ -3514,63 +3593,63 @@
               <a:defRPr sz="2200"/>
             </a:pPr>
             <a:r>
-              <a:t>gen00：原始 iCaRL（去掉 contrastive）</a:t>
-            </a:r>
-          </a:p>
-          <a:p>
-            <a:pPr>
-              <a:defRPr sz="2200"/>
-            </a:pPr>
-            <a:r>
-              <a:t>gen01：+ task adapter dim=16，从 stage1 开始</a:t>
-            </a:r>
-          </a:p>
-          <a:p>
-            <a:pPr>
-              <a:defRPr sz="2200"/>
-            </a:pPr>
-            <a:r>
-              <a:t>gen02：+ stage_epochs = 10,12,12</a:t>
-            </a:r>
-          </a:p>
-          <a:p>
-            <a:pPr>
-              <a:defRPr sz="2200"/>
-            </a:pPr>
-            <a:r>
-              <a:t>gen03：+ oldweight = 3.125</a:t>
-            </a:r>
-          </a:p>
-          <a:p>
-            <a:pPr>
-              <a:defRPr sz="2200"/>
-            </a:pPr>
-            <a:r>
-              <a:t>gen04：+ normalized NME</a:t>
-            </a:r>
-          </a:p>
-          <a:p>
-            <a:pPr>
-              <a:defRPr sz="2200"/>
-            </a:pPr>
-            <a:r>
-              <a:t>gen05：+ LwF</a:t>
-            </a:r>
-          </a:p>
-          <a:p>
-            <a:pPr>
-              <a:defRPr sz="2200"/>
-            </a:pPr>
-            <a:r>
-              <a:t>gen06：+ task affine，从 stage1 开始</a:t>
-            </a:r>
-          </a:p>
-          <a:p>
-            <a:pPr>
-              <a:defRPr sz="2200"/>
-            </a:pPr>
-            <a:r>
-              <a:t>gen07：+ hybrid NME + logits</a:t>
+              <a:t>ugen00：更合理底座（no contrastive + mem36 + replaymix2）</a:t>
+            </a:r>
+          </a:p>
+          <a:p>
+            <a:pPr>
+              <a:defRPr sz="2200"/>
+            </a:pPr>
+            <a:r>
+              <a:t>ugen01：+ task adapter dim=16，从 stage1 开始</a:t>
+            </a:r>
+          </a:p>
+          <a:p>
+            <a:pPr>
+              <a:defRPr sz="2200"/>
+            </a:pPr>
+            <a:r>
+              <a:t>ugen02：+ stage_epochs = 10,12,12</a:t>
+            </a:r>
+          </a:p>
+          <a:p>
+            <a:pPr>
+              <a:defRPr sz="2200"/>
+            </a:pPr>
+            <a:r>
+              <a:t>ugen03：+ oldweight = 3.125</a:t>
+            </a:r>
+          </a:p>
+          <a:p>
+            <a:pPr>
+              <a:defRPr sz="2200"/>
+            </a:pPr>
+            <a:r>
+              <a:t>ugen04：+ normalized NME</a:t>
+            </a:r>
+          </a:p>
+          <a:p>
+            <a:pPr>
+              <a:defRPr sz="2200"/>
+            </a:pPr>
+            <a:r>
+              <a:t>ugen05：+ LwF(0.175, T=1.5)</a:t>
+            </a:r>
+          </a:p>
+          <a:p>
+            <a:pPr>
+              <a:defRPr sz="2200"/>
+            </a:pPr>
+            <a:r>
+              <a:t>ugen06：+ task affine，从 stage1 开始</a:t>
+            </a:r>
+          </a:p>
+          <a:p>
+            <a:pPr>
+              <a:defRPr sz="2200"/>
+            </a:pPr>
+            <a:r>
+              <a:t>ugen07：+ hybrid NME+logits，统一早期开启</a:t>
             </a:r>
           </a:p>
         </p:txBody>
@@ -3623,7 +3702,7 @@
         <p:spPr>
           <a:xfrm>
             <a:off x="731520" y="1234440"/>
-            <a:ext cx="10607040" cy="5029200"/>
+            <a:ext cx="10607040" cy="5120640"/>
           </a:xfrm>
           <a:prstGeom prst="rect">
             <a:avLst/>
@@ -3640,63 +3719,63 @@
               <a:defRPr sz="2200"/>
             </a:pPr>
             <a:r>
-              <a:t>gen00: 84.72 / 56.48 / 43.29</a:t>
-            </a:r>
-          </a:p>
-          <a:p>
-            <a:pPr>
-              <a:defRPr sz="2200"/>
-            </a:pPr>
-            <a:r>
-              <a:t>gen01: 85.42 / 57.64 / 39.89</a:t>
-            </a:r>
-          </a:p>
-          <a:p>
-            <a:pPr>
-              <a:defRPr sz="2200"/>
-            </a:pPr>
-            <a:r>
-              <a:t>gen02: 85.42 / 57.79 / 39.20</a:t>
-            </a:r>
-          </a:p>
-          <a:p>
-            <a:pPr>
-              <a:defRPr sz="2200"/>
-            </a:pPr>
-            <a:r>
-              <a:t>gen03: 85.42 / 53.70 / 39.93</a:t>
-            </a:r>
-          </a:p>
-          <a:p>
-            <a:pPr>
-              <a:defRPr sz="2200"/>
-            </a:pPr>
-            <a:r>
-              <a:t>gen04: 85.42 / 54.86 / 45.22</a:t>
-            </a:r>
-          </a:p>
-          <a:p>
-            <a:pPr>
-              <a:defRPr sz="2200"/>
-            </a:pPr>
-            <a:r>
-              <a:t>gen05: 85.42 / 54.63 / 46.76</a:t>
-            </a:r>
-          </a:p>
-          <a:p>
-            <a:pPr>
-              <a:defRPr sz="2200"/>
-            </a:pPr>
-            <a:r>
-              <a:t>gen06: 84.49 / 55.86 / 43.09</a:t>
-            </a:r>
-          </a:p>
-          <a:p>
-            <a:pPr>
-              <a:defRPr sz="2200"/>
-            </a:pPr>
-            <a:r>
-              <a:t>gen07: 84.49 / 56.40 / 43.33</a:t>
+              <a:t>ugen00: 84.95 / 57.56 / 42.71</a:t>
+            </a:r>
+          </a:p>
+          <a:p>
+            <a:pPr>
+              <a:defRPr sz="2200"/>
+            </a:pPr>
+            <a:r>
+              <a:t>ugen01: 85.42 / 57.48 / 42.59</a:t>
+            </a:r>
+          </a:p>
+          <a:p>
+            <a:pPr>
+              <a:defRPr sz="2200"/>
+            </a:pPr>
+            <a:r>
+              <a:t>ugen02: 85.42 / 60.19 / 41.47</a:t>
+            </a:r>
+          </a:p>
+          <a:p>
+            <a:pPr>
+              <a:defRPr sz="2200"/>
+            </a:pPr>
+            <a:r>
+              <a:t>ugen03: 85.42 / 52.39 / 39.81</a:t>
+            </a:r>
+          </a:p>
+          <a:p>
+            <a:pPr>
+              <a:defRPr sz="2200"/>
+            </a:pPr>
+            <a:r>
+              <a:t>ugen04: 85.42 / 56.64 / 44.95</a:t>
+            </a:r>
+          </a:p>
+          <a:p>
+            <a:pPr>
+              <a:defRPr sz="2200"/>
+            </a:pPr>
+            <a:r>
+              <a:t>ugen05: 85.42 / 55.86 / 46.22</a:t>
+            </a:r>
+          </a:p>
+          <a:p>
+            <a:pPr>
+              <a:defRPr sz="2200"/>
+            </a:pPr>
+            <a:r>
+              <a:t>ugen06: 84.26 / 55.94 / 45.06</a:t>
+            </a:r>
+          </a:p>
+          <a:p>
+            <a:pPr>
+              <a:defRPr sz="2200"/>
+            </a:pPr>
+            <a:r>
+              <a:t>ugen07: 84.26 / 55.17 / 45.99</a:t>
             </a:r>
           </a:p>
         </p:txBody>
@@ -3735,7 +3814,7 @@
           <a:lstStyle/>
           <a:p>
             <a:r>
-              <a:t>前半段结论</a:t>
+              <a:t>底座本身说明什么</a:t>
             </a:r>
           </a:p>
         </p:txBody>
@@ -3749,7 +3828,7 @@
         <p:spPr>
           <a:xfrm>
             <a:off x="731520" y="1234440"/>
-            <a:ext cx="10607040" cy="5029200"/>
+            <a:ext cx="10607040" cy="5120640"/>
           </a:xfrm>
           <a:prstGeom prst="rect">
             <a:avLst/>
@@ -3766,23 +3845,23 @@
               <a:defRPr sz="2200"/>
             </a:pPr>
             <a:r>
-              <a:t>adapter16 from stage1 不是通用增益项，task3 明显变差。</a:t>
-            </a:r>
-          </a:p>
-          <a:p>
-            <a:pPr>
-              <a:defRPr sz="2200"/>
-            </a:pPr>
-            <a:r>
-              <a:t>单独把训练预算改成 10,12,12 不能修复这个问题。</a:t>
-            </a:r>
-          </a:p>
-          <a:p>
-            <a:pPr>
-              <a:defRPr sz="2200"/>
-            </a:pPr>
-            <a:r>
-              <a:t>全局 oldweight=3.125 也不适合作为通用组件，task2/task3 一起受损。</a:t>
+              <a:t>仅仅把底座改成 mem36 + replaymix2，就比上一版错误链更接近真实场景。</a:t>
+            </a:r>
+          </a:p>
+          <a:p>
+            <a:pPr>
+              <a:defRPr sz="2200"/>
+            </a:pPr>
+            <a:r>
+              <a:t>ugen00 已经到 84.95 / 57.56 / 42.71。</a:t>
+            </a:r>
+          </a:p>
+          <a:p>
+            <a:pPr>
+              <a:defRPr sz="2200"/>
+            </a:pPr>
+            <a:r>
+              <a:t>这证明之前的大差距主要来自起点过弱，而不是方法链本身全都失效。</a:t>
             </a:r>
           </a:p>
         </p:txBody>
@@ -3821,7 +3900,7 @@
           <a:lstStyle/>
           <a:p>
             <a:r>
-              <a:t>为什么 normNME 成立</a:t>
+              <a:t>adapter 全开并不成立</a:t>
             </a:r>
           </a:p>
         </p:txBody>
@@ -3835,7 +3914,7 @@
         <p:spPr>
           <a:xfrm>
             <a:off x="731520" y="1234440"/>
-            <a:ext cx="10607040" cy="5029200"/>
+            <a:ext cx="10607040" cy="5120640"/>
           </a:xfrm>
           <a:prstGeom prst="rect">
             <a:avLst/>
@@ -3852,23 +3931,23 @@
               <a:defRPr sz="2200"/>
             </a:pPr>
             <a:r>
-              <a:t>gen04 把 task3 从 39.93 拉回到 45.22。</a:t>
-            </a:r>
-          </a:p>
-          <a:p>
-            <a:pPr>
-              <a:defRPr sz="2200"/>
-            </a:pPr>
-            <a:r>
-              <a:t>它不是阶段性 trick，而是统一修 prototype classifier 的几何。</a:t>
-            </a:r>
-          </a:p>
-          <a:p>
-            <a:pPr>
-              <a:defRPr sz="2200"/>
-            </a:pPr>
-            <a:r>
-              <a:t>因此它最适合被保留为“通用 continual classifier improvement”。</a:t>
+              <a:t>ugen01 只有 task1 略升，task2/task3 没有真实改善。</a:t>
+            </a:r>
+          </a:p>
+          <a:p>
+            <a:pPr>
+              <a:defRPr sz="2200"/>
+            </a:pPr>
+            <a:r>
+              <a:t>说明 adapter16 从 stage1 全开，不是一个自然成立的全 task 通用组件。</a:t>
+            </a:r>
+          </a:p>
+          <a:p>
+            <a:pPr>
+              <a:defRPr sz="2200"/>
+            </a:pPr>
+            <a:r>
+              <a:t>它更像条件性有效的方法，需要更具体的上下文。</a:t>
             </a:r>
           </a:p>
         </p:txBody>
@@ -3907,7 +3986,7 @@
           <a:lstStyle/>
           <a:p>
             <a:r>
-              <a:t>为什么 LwF 仍然值得保留</a:t>
+              <a:t>10,12,12 的作用</a:t>
             </a:r>
           </a:p>
         </p:txBody>
@@ -3921,7 +4000,7 @@
         <p:spPr>
           <a:xfrm>
             <a:off x="731520" y="1234440"/>
-            <a:ext cx="10607040" cy="5029200"/>
+            <a:ext cx="10607040" cy="5120640"/>
           </a:xfrm>
           <a:prstGeom prst="rect">
             <a:avLst/>
@@ -3938,23 +4017,23 @@
               <a:defRPr sz="2200"/>
             </a:pPr>
             <a:r>
-              <a:t>gen05 把 task3 进一步从 45.22 拉到 46.76。</a:t>
-            </a:r>
-          </a:p>
-          <a:p>
-            <a:pPr>
-              <a:defRPr sz="2200"/>
-            </a:pPr>
-            <a:r>
-              <a:t>虽然 task2 没继续涨，但总体 score 仍然提高。</a:t>
-            </a:r>
-          </a:p>
-          <a:p>
-            <a:pPr>
-              <a:defRPr sz="2200"/>
-            </a:pPr>
-            <a:r>
-              <a:t>说明 LwF 在这条严格通用链里依旧是有效的旧知识保持机制。</a:t>
+              <a:t>ugen02 把 task2 从 57.48 拉到 60.19。</a:t>
+            </a:r>
+          </a:p>
+          <a:p>
+            <a:pPr>
+              <a:defRPr sz="2200"/>
+            </a:pPr>
+            <a:r>
+              <a:t>说明更合理的阶段训练预算仍然是有效的通用设置。</a:t>
+            </a:r>
+          </a:p>
+          <a:p>
+            <a:pPr>
+              <a:defRPr sz="2200"/>
+            </a:pPr>
+            <a:r>
+              <a:t>但它本身不是万能修正，task3 仍然偏低。</a:t>
             </a:r>
           </a:p>
         </p:txBody>
@@ -3993,7 +4072,7 @@
           <a:lstStyle/>
           <a:p>
             <a:r>
-              <a:t>为什么 affine 和 hybrid 没成立</a:t>
+              <a:t>为什么 oldweight 不适合写成通用组件</a:t>
             </a:r>
           </a:p>
         </p:txBody>
@@ -4007,7 +4086,7 @@
         <p:spPr>
           <a:xfrm>
             <a:off x="731520" y="1234440"/>
-            <a:ext cx="10607040" cy="5029200"/>
+            <a:ext cx="10607040" cy="5120640"/>
           </a:xfrm>
           <a:prstGeom prst="rect">
             <a:avLst/>
@@ -4024,31 +4103,23 @@
               <a:defRPr sz="2200"/>
             </a:pPr>
             <a:r>
-              <a:t>gen06 affineall: 84.49 / 55.86 / 43.09</a:t>
-            </a:r>
-          </a:p>
-          <a:p>
-            <a:pPr>
-              <a:defRPr sz="2200"/>
-            </a:pPr>
-            <a:r>
-              <a:t>gen07 hybridall: 84.49 / 56.40 / 43.33</a:t>
-            </a:r>
-          </a:p>
-          <a:p>
-            <a:pPr>
-              <a:defRPr sz="2200"/>
-            </a:pPr>
-            <a:r>
-              <a:t>这说明它们不能机械地从 stage1/早期统一启用。</a:t>
-            </a:r>
-          </a:p>
-          <a:p>
-            <a:pPr>
-              <a:defRPr sz="2200"/>
-            </a:pPr>
-            <a:r>
-              <a:t>更准确的定位应当是：条件性有效，而不是通用主线组件。</a:t>
+              <a:t>ugen03 变成 85.42 / 52.39 / 39.81。</a:t>
+            </a:r>
+          </a:p>
+          <a:p>
+            <a:pPr>
+              <a:defRPr sz="2200"/>
+            </a:pPr>
+            <a:r>
+              <a:t>这说明 oldweight=3.125 不能机械地全局加入通用链。</a:t>
+            </a:r>
+          </a:p>
+          <a:p>
+            <a:pPr>
+              <a:defRPr sz="2200"/>
+            </a:pPr>
+            <a:r>
+              <a:t>它只有在更具体、更条件性的主线里才成立。</a:t>
             </a:r>
           </a:p>
         </p:txBody>
@@ -4087,7 +4158,7 @@
           <a:lstStyle/>
           <a:p>
             <a:r>
-              <a:t>通用链最终保留什么</a:t>
+              <a:t>normNME 与 LwF 的地位</a:t>
             </a:r>
           </a:p>
         </p:txBody>
@@ -4101,7 +4172,7 @@
         <p:spPr>
           <a:xfrm>
             <a:off x="731520" y="1234440"/>
-            <a:ext cx="10607040" cy="5029200"/>
+            <a:ext cx="10607040" cy="5120640"/>
           </a:xfrm>
           <a:prstGeom prst="rect">
             <a:avLst/>
@@ -4118,31 +4189,23 @@
               <a:defRPr sz="2200"/>
             </a:pPr>
             <a:r>
-              <a:t>去掉 contrastive</a:t>
-            </a:r>
-          </a:p>
-          <a:p>
-            <a:pPr>
-              <a:defRPr sz="2200"/>
-            </a:pPr>
-            <a:r>
-              <a:t>normalized NME</a:t>
-            </a:r>
-          </a:p>
-          <a:p>
-            <a:pPr>
-              <a:defRPr sz="2200"/>
-            </a:pPr>
-            <a:r>
-              <a:t>LwF</a:t>
-            </a:r>
-          </a:p>
-          <a:p>
-            <a:pPr>
-              <a:defRPr sz="2200"/>
-            </a:pPr>
-            <a:r>
-              <a:t>这三项是本轮最稳、最适合写成通用 continual 方法的核心。</a:t>
+              <a:t>ugen04: normNME -&gt; 85.42 / 56.64 / 44.95</a:t>
+            </a:r>
+          </a:p>
+          <a:p>
+            <a:pPr>
+              <a:defRPr sz="2200"/>
+            </a:pPr>
+            <a:r>
+              <a:t>ugen05: +LwF -&gt; 85.42 / 55.86 / 46.22</a:t>
+            </a:r>
+          </a:p>
+          <a:p>
+            <a:pPr>
+              <a:defRPr sz="2200"/>
+            </a:pPr>
+            <a:r>
+              <a:t>说明这两项在更合理底座上仍然是最像“通用 continual 组件”的方法。</a:t>
             </a:r>
           </a:p>
         </p:txBody>

</xml_diff>